<commit_message>
docs: professional PDF dossier with verified data & 25+ jury questions
- Updated stats with World Bank 2024 verified data:
  Agriculture = 21.5% PIB UEMOA (not 35%), 51% workforce, < 6% credit
  Population: 151.7M, 30M+ agricultural workers, 209M mobile accounts
- Added comprehensive Q&A sections organized by jury profile:
  - Directeurs de banques (4 questions)
  - Investisseurs (4 questions)
  - Dirigeants UEMOA/BCEAO (5 questions)
  - Questions pieges/destabilisation (4 questions)
- Visual elements: stat cards, flow diagrams, score ring, tables
- 15 pages total covering all aspects of the pitch

Co-Authored-By: Claude Opus 4.6 <noreply@anthropic.com>
</commit_message>
<xml_diff>
--- a/FRESCOOP_PITCH_v2.pptx
+++ b/FRESCOOP_PITCH_v2.pptx
@@ -5,14 +5,14 @@
     <p:sldMasterId id="2147483648" r:id="rId1"/>
   </p:sldMasterIdLst>
   <p:sldIdLst>
-    <p:sldId id="256" r:id="rId7"/>
-    <p:sldId id="257" r:id="rId8"/>
-    <p:sldId id="258" r:id="rId9"/>
-    <p:sldId id="259" r:id="rId10"/>
-    <p:sldId id="260" r:id="rId11"/>
-    <p:sldId id="261" r:id="rId12"/>
+    <p:sldId id="256" r:id="rId2"/>
+    <p:sldId id="257" r:id="rId3"/>
+    <p:sldId id="258" r:id="rId4"/>
+    <p:sldId id="259" r:id="rId5"/>
+    <p:sldId id="260" r:id="rId6"/>
+    <p:sldId id="261" r:id="rId7"/>
   </p:sldIdLst>
-  <p:sldSz cx="12191695" cy="6858000" type="screen4x3"/>
+  <p:sldSz cx="12192000" cy="6858000"/>
   <p:notesSz cx="6858000" cy="9144000"/>
   <p:defaultTextStyle>
     <a:defPPr>
@@ -109,6 +109,22 @@
       </a:defRPr>
     </a:lvl9pPr>
   </p:defaultTextStyle>
+  <p:extLst>
+    <p:ext uri="{EFAFB233-063F-42B5-8137-9DF3F51BA10A}">
+      <p15:sldGuideLst xmlns:p15="http://schemas.microsoft.com/office/powerpoint/2012/main">
+        <p15:guide id="1" orient="horz" pos="2160">
+          <p15:clr>
+            <a:srgbClr val="A4A3A4"/>
+          </p15:clr>
+        </p15:guide>
+        <p15:guide id="2" pos="2880">
+          <p15:clr>
+            <a:srgbClr val="A4A3A4"/>
+          </p15:clr>
+        </p15:guide>
+      </p15:sldGuideLst>
+    </p:ext>
+  </p:extLst>
 </p:presentation>
 </file>
 
@@ -150,10 +166,9 @@
           <a:lstStyle/>
           <a:p>
             <a:r>
-              <a:rPr lang="en-US" smtClean="0"/>
+              <a:rPr lang="en-US"/>
               <a:t>Click to edit Master title style</a:t>
             </a:r>
-            <a:endParaRPr lang="en-US"/>
           </a:p>
         </p:txBody>
       </p:sp>
@@ -269,10 +284,9 @@
           </a:lstStyle>
           <a:p>
             <a:r>
-              <a:rPr lang="en-US" smtClean="0"/>
+              <a:rPr lang="en-US"/>
               <a:t>Click to edit Master subtitle style</a:t>
             </a:r>
-            <a:endParaRPr lang="en-US"/>
           </a:p>
         </p:txBody>
       </p:sp>
@@ -293,7 +307,7 @@
           <a:p>
             <a:fld id="{5BCAD085-E8A6-8845-BD4E-CB4CCA059FC4}" type="datetimeFigureOut">
               <a:rPr lang="en-US" smtClean="0"/>
-              <a:t>1/27/13</a:t>
+              <a:t>5/19/2026</a:t>
             </a:fld>
             <a:endParaRPr lang="en-US"/>
           </a:p>
@@ -335,7 +349,7 @@
           <a:p>
             <a:fld id="{C1FF6DA9-008F-8B48-92A6-B652298478BF}" type="slidenum">
               <a:rPr lang="en-US" smtClean="0"/>
-              <a:t>‹#›</a:t>
+              <a:t>‹N°›</a:t>
             </a:fld>
             <a:endParaRPr lang="en-US"/>
           </a:p>
@@ -387,10 +401,9 @@
           <a:lstStyle/>
           <a:p>
             <a:r>
-              <a:rPr lang="en-US" smtClean="0"/>
+              <a:rPr lang="en-US"/>
               <a:t>Click to edit Master title style</a:t>
             </a:r>
-            <a:endParaRPr lang="en-US"/>
           </a:p>
         </p:txBody>
       </p:sp>
@@ -411,38 +424,37 @@
           <a:p>
             <a:pPr lvl="0"/>
             <a:r>
-              <a:rPr lang="en-US" smtClean="0"/>
+              <a:rPr lang="en-US"/>
               <a:t>Click to edit Master text styles</a:t>
             </a:r>
           </a:p>
           <a:p>
             <a:pPr lvl="1"/>
             <a:r>
-              <a:rPr lang="en-US" smtClean="0"/>
+              <a:rPr lang="en-US"/>
               <a:t>Second level</a:t>
             </a:r>
           </a:p>
           <a:p>
             <a:pPr lvl="2"/>
             <a:r>
-              <a:rPr lang="en-US" smtClean="0"/>
+              <a:rPr lang="en-US"/>
               <a:t>Third level</a:t>
             </a:r>
           </a:p>
           <a:p>
             <a:pPr lvl="3"/>
             <a:r>
-              <a:rPr lang="en-US" smtClean="0"/>
+              <a:rPr lang="en-US"/>
               <a:t>Fourth level</a:t>
             </a:r>
           </a:p>
           <a:p>
             <a:pPr lvl="4"/>
             <a:r>
-              <a:rPr lang="en-US" smtClean="0"/>
+              <a:rPr lang="en-US"/>
               <a:t>Fifth level</a:t>
             </a:r>
-            <a:endParaRPr lang="en-US"/>
           </a:p>
         </p:txBody>
       </p:sp>
@@ -463,7 +475,7 @@
           <a:p>
             <a:fld id="{5BCAD085-E8A6-8845-BD4E-CB4CCA059FC4}" type="datetimeFigureOut">
               <a:rPr lang="en-US" smtClean="0"/>
-              <a:t>1/27/13</a:t>
+              <a:t>5/19/2026</a:t>
             </a:fld>
             <a:endParaRPr lang="en-US"/>
           </a:p>
@@ -505,7 +517,7 @@
           <a:p>
             <a:fld id="{C1FF6DA9-008F-8B48-92A6-B652298478BF}" type="slidenum">
               <a:rPr lang="en-US" smtClean="0"/>
-              <a:t>‹#›</a:t>
+              <a:t>‹N°›</a:t>
             </a:fld>
             <a:endParaRPr lang="en-US"/>
           </a:p>
@@ -562,10 +574,9 @@
           <a:lstStyle/>
           <a:p>
             <a:r>
-              <a:rPr lang="en-US" smtClean="0"/>
+              <a:rPr lang="en-US"/>
               <a:t>Click to edit Master title style</a:t>
             </a:r>
-            <a:endParaRPr lang="en-US"/>
           </a:p>
         </p:txBody>
       </p:sp>
@@ -591,38 +602,37 @@
           <a:p>
             <a:pPr lvl="0"/>
             <a:r>
-              <a:rPr lang="en-US" smtClean="0"/>
+              <a:rPr lang="en-US"/>
               <a:t>Click to edit Master text styles</a:t>
             </a:r>
           </a:p>
           <a:p>
             <a:pPr lvl="1"/>
             <a:r>
-              <a:rPr lang="en-US" smtClean="0"/>
+              <a:rPr lang="en-US"/>
               <a:t>Second level</a:t>
             </a:r>
           </a:p>
           <a:p>
             <a:pPr lvl="2"/>
             <a:r>
-              <a:rPr lang="en-US" smtClean="0"/>
+              <a:rPr lang="en-US"/>
               <a:t>Third level</a:t>
             </a:r>
           </a:p>
           <a:p>
             <a:pPr lvl="3"/>
             <a:r>
-              <a:rPr lang="en-US" smtClean="0"/>
+              <a:rPr lang="en-US"/>
               <a:t>Fourth level</a:t>
             </a:r>
           </a:p>
           <a:p>
             <a:pPr lvl="4"/>
             <a:r>
-              <a:rPr lang="en-US" smtClean="0"/>
+              <a:rPr lang="en-US"/>
               <a:t>Fifth level</a:t>
             </a:r>
-            <a:endParaRPr lang="en-US"/>
           </a:p>
         </p:txBody>
       </p:sp>
@@ -643,7 +653,7 @@
           <a:p>
             <a:fld id="{5BCAD085-E8A6-8845-BD4E-CB4CCA059FC4}" type="datetimeFigureOut">
               <a:rPr lang="en-US" smtClean="0"/>
-              <a:t>1/27/13</a:t>
+              <a:t>5/19/2026</a:t>
             </a:fld>
             <a:endParaRPr lang="en-US"/>
           </a:p>
@@ -685,7 +695,7 @@
           <a:p>
             <a:fld id="{C1FF6DA9-008F-8B48-92A6-B652298478BF}" type="slidenum">
               <a:rPr lang="en-US" smtClean="0"/>
-              <a:t>‹#›</a:t>
+              <a:t>‹N°›</a:t>
             </a:fld>
             <a:endParaRPr lang="en-US"/>
           </a:p>
@@ -737,10 +747,9 @@
           <a:lstStyle/>
           <a:p>
             <a:r>
-              <a:rPr lang="en-US" smtClean="0"/>
+              <a:rPr lang="en-US"/>
               <a:t>Click to edit Master title style</a:t>
             </a:r>
-            <a:endParaRPr lang="en-US"/>
           </a:p>
         </p:txBody>
       </p:sp>
@@ -761,38 +770,37 @@
           <a:p>
             <a:pPr lvl="0"/>
             <a:r>
-              <a:rPr lang="en-US" smtClean="0"/>
+              <a:rPr lang="en-US"/>
               <a:t>Click to edit Master text styles</a:t>
             </a:r>
           </a:p>
           <a:p>
             <a:pPr lvl="1"/>
             <a:r>
-              <a:rPr lang="en-US" smtClean="0"/>
+              <a:rPr lang="en-US"/>
               <a:t>Second level</a:t>
             </a:r>
           </a:p>
           <a:p>
             <a:pPr lvl="2"/>
             <a:r>
-              <a:rPr lang="en-US" smtClean="0"/>
+              <a:rPr lang="en-US"/>
               <a:t>Third level</a:t>
             </a:r>
           </a:p>
           <a:p>
             <a:pPr lvl="3"/>
             <a:r>
-              <a:rPr lang="en-US" smtClean="0"/>
+              <a:rPr lang="en-US"/>
               <a:t>Fourth level</a:t>
             </a:r>
           </a:p>
           <a:p>
             <a:pPr lvl="4"/>
             <a:r>
-              <a:rPr lang="en-US" smtClean="0"/>
+              <a:rPr lang="en-US"/>
               <a:t>Fifth level</a:t>
             </a:r>
-            <a:endParaRPr lang="en-US"/>
           </a:p>
         </p:txBody>
       </p:sp>
@@ -813,7 +821,7 @@
           <a:p>
             <a:fld id="{5BCAD085-E8A6-8845-BD4E-CB4CCA059FC4}" type="datetimeFigureOut">
               <a:rPr lang="en-US" smtClean="0"/>
-              <a:t>1/27/13</a:t>
+              <a:t>5/19/2026</a:t>
             </a:fld>
             <a:endParaRPr lang="en-US"/>
           </a:p>
@@ -855,7 +863,7 @@
           <a:p>
             <a:fld id="{C1FF6DA9-008F-8B48-92A6-B652298478BF}" type="slidenum">
               <a:rPr lang="en-US" smtClean="0"/>
-              <a:t>‹#›</a:t>
+              <a:t>‹N°›</a:t>
             </a:fld>
             <a:endParaRPr lang="en-US"/>
           </a:p>
@@ -916,10 +924,9 @@
           </a:lstStyle>
           <a:p>
             <a:r>
-              <a:rPr lang="en-US" smtClean="0"/>
+              <a:rPr lang="en-US"/>
               <a:t>Click to edit Master title style</a:t>
             </a:r>
-            <a:endParaRPr lang="en-US"/>
           </a:p>
         </p:txBody>
       </p:sp>
@@ -1036,7 +1043,7 @@
           <a:p>
             <a:pPr lvl="0"/>
             <a:r>
-              <a:rPr lang="en-US" smtClean="0"/>
+              <a:rPr lang="en-US"/>
               <a:t>Click to edit Master text styles</a:t>
             </a:r>
           </a:p>
@@ -1059,7 +1066,7 @@
           <a:p>
             <a:fld id="{5BCAD085-E8A6-8845-BD4E-CB4CCA059FC4}" type="datetimeFigureOut">
               <a:rPr lang="en-US" smtClean="0"/>
-              <a:t>1/27/13</a:t>
+              <a:t>5/19/2026</a:t>
             </a:fld>
             <a:endParaRPr lang="en-US"/>
           </a:p>
@@ -1101,7 +1108,7 @@
           <a:p>
             <a:fld id="{C1FF6DA9-008F-8B48-92A6-B652298478BF}" type="slidenum">
               <a:rPr lang="en-US" smtClean="0"/>
-              <a:t>‹#›</a:t>
+              <a:t>‹N°›</a:t>
             </a:fld>
             <a:endParaRPr lang="en-US"/>
           </a:p>
@@ -1153,10 +1160,9 @@
           <a:lstStyle/>
           <a:p>
             <a:r>
-              <a:rPr lang="en-US" smtClean="0"/>
+              <a:rPr lang="en-US"/>
               <a:t>Click to edit Master title style</a:t>
             </a:r>
-            <a:endParaRPr lang="en-US"/>
           </a:p>
         </p:txBody>
       </p:sp>
@@ -1210,38 +1216,37 @@
           <a:p>
             <a:pPr lvl="0"/>
             <a:r>
-              <a:rPr lang="en-US" smtClean="0"/>
+              <a:rPr lang="en-US"/>
               <a:t>Click to edit Master text styles</a:t>
             </a:r>
           </a:p>
           <a:p>
             <a:pPr lvl="1"/>
             <a:r>
-              <a:rPr lang="en-US" smtClean="0"/>
+              <a:rPr lang="en-US"/>
               <a:t>Second level</a:t>
             </a:r>
           </a:p>
           <a:p>
             <a:pPr lvl="2"/>
             <a:r>
-              <a:rPr lang="en-US" smtClean="0"/>
+              <a:rPr lang="en-US"/>
               <a:t>Third level</a:t>
             </a:r>
           </a:p>
           <a:p>
             <a:pPr lvl="3"/>
             <a:r>
-              <a:rPr lang="en-US" smtClean="0"/>
+              <a:rPr lang="en-US"/>
               <a:t>Fourth level</a:t>
             </a:r>
           </a:p>
           <a:p>
             <a:pPr lvl="4"/>
             <a:r>
-              <a:rPr lang="en-US" smtClean="0"/>
+              <a:rPr lang="en-US"/>
               <a:t>Fifth level</a:t>
             </a:r>
-            <a:endParaRPr lang="en-US"/>
           </a:p>
         </p:txBody>
       </p:sp>
@@ -1295,38 +1300,37 @@
           <a:p>
             <a:pPr lvl="0"/>
             <a:r>
-              <a:rPr lang="en-US" smtClean="0"/>
+              <a:rPr lang="en-US"/>
               <a:t>Click to edit Master text styles</a:t>
             </a:r>
           </a:p>
           <a:p>
             <a:pPr lvl="1"/>
             <a:r>
-              <a:rPr lang="en-US" smtClean="0"/>
+              <a:rPr lang="en-US"/>
               <a:t>Second level</a:t>
             </a:r>
           </a:p>
           <a:p>
             <a:pPr lvl="2"/>
             <a:r>
-              <a:rPr lang="en-US" smtClean="0"/>
+              <a:rPr lang="en-US"/>
               <a:t>Third level</a:t>
             </a:r>
           </a:p>
           <a:p>
             <a:pPr lvl="3"/>
             <a:r>
-              <a:rPr lang="en-US" smtClean="0"/>
+              <a:rPr lang="en-US"/>
               <a:t>Fourth level</a:t>
             </a:r>
           </a:p>
           <a:p>
             <a:pPr lvl="4"/>
             <a:r>
-              <a:rPr lang="en-US" smtClean="0"/>
+              <a:rPr lang="en-US"/>
               <a:t>Fifth level</a:t>
             </a:r>
-            <a:endParaRPr lang="en-US"/>
           </a:p>
         </p:txBody>
       </p:sp>
@@ -1347,7 +1351,7 @@
           <a:p>
             <a:fld id="{5BCAD085-E8A6-8845-BD4E-CB4CCA059FC4}" type="datetimeFigureOut">
               <a:rPr lang="en-US" smtClean="0"/>
-              <a:t>1/27/13</a:t>
+              <a:t>5/19/2026</a:t>
             </a:fld>
             <a:endParaRPr lang="en-US"/>
           </a:p>
@@ -1389,7 +1393,7 @@
           <a:p>
             <a:fld id="{C1FF6DA9-008F-8B48-92A6-B652298478BF}" type="slidenum">
               <a:rPr lang="en-US" smtClean="0"/>
-              <a:t>‹#›</a:t>
+              <a:t>‹N°›</a:t>
             </a:fld>
             <a:endParaRPr lang="en-US"/>
           </a:p>
@@ -1445,10 +1449,9 @@
           </a:lstStyle>
           <a:p>
             <a:r>
-              <a:rPr lang="en-US" smtClean="0"/>
+              <a:rPr lang="en-US"/>
               <a:t>Click to edit Master title style</a:t>
             </a:r>
-            <a:endParaRPr lang="en-US"/>
           </a:p>
         </p:txBody>
       </p:sp>
@@ -1511,7 +1514,7 @@
           <a:p>
             <a:pPr lvl="0"/>
             <a:r>
-              <a:rPr lang="en-US" smtClean="0"/>
+              <a:rPr lang="en-US"/>
               <a:t>Click to edit Master text styles</a:t>
             </a:r>
           </a:p>
@@ -1567,38 +1570,37 @@
           <a:p>
             <a:pPr lvl="0"/>
             <a:r>
-              <a:rPr lang="en-US" smtClean="0"/>
+              <a:rPr lang="en-US"/>
               <a:t>Click to edit Master text styles</a:t>
             </a:r>
           </a:p>
           <a:p>
             <a:pPr lvl="1"/>
             <a:r>
-              <a:rPr lang="en-US" smtClean="0"/>
+              <a:rPr lang="en-US"/>
               <a:t>Second level</a:t>
             </a:r>
           </a:p>
           <a:p>
             <a:pPr lvl="2"/>
             <a:r>
-              <a:rPr lang="en-US" smtClean="0"/>
+              <a:rPr lang="en-US"/>
               <a:t>Third level</a:t>
             </a:r>
           </a:p>
           <a:p>
             <a:pPr lvl="3"/>
             <a:r>
-              <a:rPr lang="en-US" smtClean="0"/>
+              <a:rPr lang="en-US"/>
               <a:t>Fourth level</a:t>
             </a:r>
           </a:p>
           <a:p>
             <a:pPr lvl="4"/>
             <a:r>
-              <a:rPr lang="en-US" smtClean="0"/>
+              <a:rPr lang="en-US"/>
               <a:t>Fifth level</a:t>
             </a:r>
-            <a:endParaRPr lang="en-US"/>
           </a:p>
         </p:txBody>
       </p:sp>
@@ -1661,7 +1663,7 @@
           <a:p>
             <a:pPr lvl="0"/>
             <a:r>
-              <a:rPr lang="en-US" smtClean="0"/>
+              <a:rPr lang="en-US"/>
               <a:t>Click to edit Master text styles</a:t>
             </a:r>
           </a:p>
@@ -1717,38 +1719,37 @@
           <a:p>
             <a:pPr lvl="0"/>
             <a:r>
-              <a:rPr lang="en-US" smtClean="0"/>
+              <a:rPr lang="en-US"/>
               <a:t>Click to edit Master text styles</a:t>
             </a:r>
           </a:p>
           <a:p>
             <a:pPr lvl="1"/>
             <a:r>
-              <a:rPr lang="en-US" smtClean="0"/>
+              <a:rPr lang="en-US"/>
               <a:t>Second level</a:t>
             </a:r>
           </a:p>
           <a:p>
             <a:pPr lvl="2"/>
             <a:r>
-              <a:rPr lang="en-US" smtClean="0"/>
+              <a:rPr lang="en-US"/>
               <a:t>Third level</a:t>
             </a:r>
           </a:p>
           <a:p>
             <a:pPr lvl="3"/>
             <a:r>
-              <a:rPr lang="en-US" smtClean="0"/>
+              <a:rPr lang="en-US"/>
               <a:t>Fourth level</a:t>
             </a:r>
           </a:p>
           <a:p>
             <a:pPr lvl="4"/>
             <a:r>
-              <a:rPr lang="en-US" smtClean="0"/>
+              <a:rPr lang="en-US"/>
               <a:t>Fifth level</a:t>
             </a:r>
-            <a:endParaRPr lang="en-US"/>
           </a:p>
         </p:txBody>
       </p:sp>
@@ -1769,7 +1770,7 @@
           <a:p>
             <a:fld id="{5BCAD085-E8A6-8845-BD4E-CB4CCA059FC4}" type="datetimeFigureOut">
               <a:rPr lang="en-US" smtClean="0"/>
-              <a:t>1/27/13</a:t>
+              <a:t>5/19/2026</a:t>
             </a:fld>
             <a:endParaRPr lang="en-US"/>
           </a:p>
@@ -1811,7 +1812,7 @@
           <a:p>
             <a:fld id="{C1FF6DA9-008F-8B48-92A6-B652298478BF}" type="slidenum">
               <a:rPr lang="en-US" smtClean="0"/>
-              <a:t>‹#›</a:t>
+              <a:t>‹N°›</a:t>
             </a:fld>
             <a:endParaRPr lang="en-US"/>
           </a:p>
@@ -1863,10 +1864,9 @@
           <a:lstStyle/>
           <a:p>
             <a:r>
-              <a:rPr lang="en-US" smtClean="0"/>
+              <a:rPr lang="en-US"/>
               <a:t>Click to edit Master title style</a:t>
             </a:r>
-            <a:endParaRPr lang="en-US"/>
           </a:p>
         </p:txBody>
       </p:sp>
@@ -1887,7 +1887,7 @@
           <a:p>
             <a:fld id="{5BCAD085-E8A6-8845-BD4E-CB4CCA059FC4}" type="datetimeFigureOut">
               <a:rPr lang="en-US" smtClean="0"/>
-              <a:t>1/27/13</a:t>
+              <a:t>5/19/2026</a:t>
             </a:fld>
             <a:endParaRPr lang="en-US"/>
           </a:p>
@@ -1929,7 +1929,7 @@
           <a:p>
             <a:fld id="{C1FF6DA9-008F-8B48-92A6-B652298478BF}" type="slidenum">
               <a:rPr lang="en-US" smtClean="0"/>
-              <a:t>‹#›</a:t>
+              <a:t>‹N°›</a:t>
             </a:fld>
             <a:endParaRPr lang="en-US"/>
           </a:p>
@@ -1982,7 +1982,7 @@
           <a:p>
             <a:fld id="{5BCAD085-E8A6-8845-BD4E-CB4CCA059FC4}" type="datetimeFigureOut">
               <a:rPr lang="en-US" smtClean="0"/>
-              <a:t>1/27/13</a:t>
+              <a:t>5/19/2026</a:t>
             </a:fld>
             <a:endParaRPr lang="en-US"/>
           </a:p>
@@ -2024,7 +2024,7 @@
           <a:p>
             <a:fld id="{C1FF6DA9-008F-8B48-92A6-B652298478BF}" type="slidenum">
               <a:rPr lang="en-US" smtClean="0"/>
-              <a:t>‹#›</a:t>
+              <a:t>‹N°›</a:t>
             </a:fld>
             <a:endParaRPr lang="en-US"/>
           </a:p>
@@ -2085,10 +2085,9 @@
           </a:lstStyle>
           <a:p>
             <a:r>
-              <a:rPr lang="en-US" smtClean="0"/>
+              <a:rPr lang="en-US"/>
               <a:t>Click to edit Master title style</a:t>
             </a:r>
-            <a:endParaRPr lang="en-US"/>
           </a:p>
         </p:txBody>
       </p:sp>
@@ -2142,38 +2141,37 @@
           <a:p>
             <a:pPr lvl="0"/>
             <a:r>
-              <a:rPr lang="en-US" smtClean="0"/>
+              <a:rPr lang="en-US"/>
               <a:t>Click to edit Master text styles</a:t>
             </a:r>
           </a:p>
           <a:p>
             <a:pPr lvl="1"/>
             <a:r>
-              <a:rPr lang="en-US" smtClean="0"/>
+              <a:rPr lang="en-US"/>
               <a:t>Second level</a:t>
             </a:r>
           </a:p>
           <a:p>
             <a:pPr lvl="2"/>
             <a:r>
-              <a:rPr lang="en-US" smtClean="0"/>
+              <a:rPr lang="en-US"/>
               <a:t>Third level</a:t>
             </a:r>
           </a:p>
           <a:p>
             <a:pPr lvl="3"/>
             <a:r>
-              <a:rPr lang="en-US" smtClean="0"/>
+              <a:rPr lang="en-US"/>
               <a:t>Fourth level</a:t>
             </a:r>
           </a:p>
           <a:p>
             <a:pPr lvl="4"/>
             <a:r>
-              <a:rPr lang="en-US" smtClean="0"/>
+              <a:rPr lang="en-US"/>
               <a:t>Fifth level</a:t>
             </a:r>
-            <a:endParaRPr lang="en-US"/>
           </a:p>
         </p:txBody>
       </p:sp>
@@ -2236,7 +2234,7 @@
           <a:p>
             <a:pPr lvl="0"/>
             <a:r>
-              <a:rPr lang="en-US" smtClean="0"/>
+              <a:rPr lang="en-US"/>
               <a:t>Click to edit Master text styles</a:t>
             </a:r>
           </a:p>
@@ -2259,7 +2257,7 @@
           <a:p>
             <a:fld id="{5BCAD085-E8A6-8845-BD4E-CB4CCA059FC4}" type="datetimeFigureOut">
               <a:rPr lang="en-US" smtClean="0"/>
-              <a:t>1/27/13</a:t>
+              <a:t>5/19/2026</a:t>
             </a:fld>
             <a:endParaRPr lang="en-US"/>
           </a:p>
@@ -2301,7 +2299,7 @@
           <a:p>
             <a:fld id="{C1FF6DA9-008F-8B48-92A6-B652298478BF}" type="slidenum">
               <a:rPr lang="en-US" smtClean="0"/>
-              <a:t>‹#›</a:t>
+              <a:t>‹N°›</a:t>
             </a:fld>
             <a:endParaRPr lang="en-US"/>
           </a:p>
@@ -2362,10 +2360,9 @@
           </a:lstStyle>
           <a:p>
             <a:r>
-              <a:rPr lang="en-US" smtClean="0"/>
+              <a:rPr lang="en-US"/>
               <a:t>Click to edit Master title style</a:t>
             </a:r>
-            <a:endParaRPr lang="en-US"/>
           </a:p>
         </p:txBody>
       </p:sp>
@@ -2489,7 +2486,7 @@
           <a:p>
             <a:pPr lvl="0"/>
             <a:r>
-              <a:rPr lang="en-US" smtClean="0"/>
+              <a:rPr lang="en-US"/>
               <a:t>Click to edit Master text styles</a:t>
             </a:r>
           </a:p>
@@ -2512,7 +2509,7 @@
           <a:p>
             <a:fld id="{5BCAD085-E8A6-8845-BD4E-CB4CCA059FC4}" type="datetimeFigureOut">
               <a:rPr lang="en-US" smtClean="0"/>
-              <a:t>1/27/13</a:t>
+              <a:t>5/19/2026</a:t>
             </a:fld>
             <a:endParaRPr lang="en-US"/>
           </a:p>
@@ -2554,7 +2551,7 @@
           <a:p>
             <a:fld id="{C1FF6DA9-008F-8B48-92A6-B652298478BF}" type="slidenum">
               <a:rPr lang="en-US" smtClean="0"/>
-              <a:t>‹#›</a:t>
+              <a:t>‹N°›</a:t>
             </a:fld>
             <a:endParaRPr lang="en-US"/>
           </a:p>
@@ -2621,10 +2618,9 @@
           <a:lstStyle/>
           <a:p>
             <a:r>
-              <a:rPr lang="en-US" smtClean="0"/>
+              <a:rPr lang="en-US"/>
               <a:t>Click to edit Master title style</a:t>
             </a:r>
-            <a:endParaRPr lang="en-US"/>
           </a:p>
         </p:txBody>
       </p:sp>
@@ -2655,38 +2651,37 @@
           <a:p>
             <a:pPr lvl="0"/>
             <a:r>
-              <a:rPr lang="en-US" smtClean="0"/>
+              <a:rPr lang="en-US"/>
               <a:t>Click to edit Master text styles</a:t>
             </a:r>
           </a:p>
           <a:p>
             <a:pPr lvl="1"/>
             <a:r>
-              <a:rPr lang="en-US" smtClean="0"/>
+              <a:rPr lang="en-US"/>
               <a:t>Second level</a:t>
             </a:r>
           </a:p>
           <a:p>
             <a:pPr lvl="2"/>
             <a:r>
-              <a:rPr lang="en-US" smtClean="0"/>
+              <a:rPr lang="en-US"/>
               <a:t>Third level</a:t>
             </a:r>
           </a:p>
           <a:p>
             <a:pPr lvl="3"/>
             <a:r>
-              <a:rPr lang="en-US" smtClean="0"/>
+              <a:rPr lang="en-US"/>
               <a:t>Fourth level</a:t>
             </a:r>
           </a:p>
           <a:p>
             <a:pPr lvl="4"/>
             <a:r>
-              <a:rPr lang="en-US" smtClean="0"/>
+              <a:rPr lang="en-US"/>
               <a:t>Fifth level</a:t>
             </a:r>
-            <a:endParaRPr lang="en-US"/>
           </a:p>
         </p:txBody>
       </p:sp>
@@ -2725,7 +2720,7 @@
           <a:p>
             <a:fld id="{5BCAD085-E8A6-8845-BD4E-CB4CCA059FC4}" type="datetimeFigureOut">
               <a:rPr lang="en-US" smtClean="0"/>
-              <a:t>1/27/13</a:t>
+              <a:t>5/19/2026</a:t>
             </a:fld>
             <a:endParaRPr lang="en-US"/>
           </a:p>
@@ -2803,7 +2798,7 @@
           <a:p>
             <a:fld id="{C1FF6DA9-008F-8B48-92A6-B652298478BF}" type="slidenum">
               <a:rPr lang="en-US" smtClean="0"/>
-              <a:t>‹#›</a:t>
+              <a:t>‹N°›</a:t>
             </a:fld>
             <a:endParaRPr lang="en-US"/>
           </a:p>
@@ -3084,7 +3079,7 @@
 </file>
 
 <file path=ppt/slides/slide1.xml><?xml version="1.0" encoding="utf-8"?>
-<p:sld xmlns:a="http://schemas.openxmlformats.org/drawingml/2006/main" xmlns:p="http://schemas.openxmlformats.org/presentationml/2006/main" xmlns:r="http://schemas.openxmlformats.org/officeDocument/2006/relationships">
+<p:sld xmlns:a="http://schemas.openxmlformats.org/drawingml/2006/main" xmlns:r="http://schemas.openxmlformats.org/officeDocument/2006/relationships" xmlns:p="http://schemas.openxmlformats.org/presentationml/2006/main">
   <p:cSld>
     <p:bg>
       <p:bgPr>
@@ -3100,7 +3095,14 @@
         <p:cNvGrpSpPr/>
         <p:nvPr/>
       </p:nvGrpSpPr>
-      <p:grpSpPr/>
+      <p:grpSpPr>
+        <a:xfrm>
+          <a:off x="0" y="0"/>
+          <a:ext cx="0" cy="0"/>
+          <a:chOff x="0" y="0"/>
+          <a:chExt cx="0" cy="0"/>
+        </a:xfrm>
+      </p:grpSpPr>
       <p:sp>
         <p:nvSpPr>
           <p:cNvPr id="2" name="Rectangle 1"/>
@@ -3141,6 +3143,7 @@
           <a:lstStyle/>
           <a:p>
             <a:pPr algn="ctr"/>
+            <a:endParaRPr/>
           </a:p>
         </p:txBody>
       </p:sp>
@@ -3188,7 +3191,7 @@
         </p:nvSpPr>
         <p:spPr>
           <a:xfrm>
-            <a:off x="731520" y="1828800"/>
+            <a:off x="731520" y="1472184"/>
             <a:ext cx="7315200" cy="1097280"/>
           </a:xfrm>
           <a:prstGeom prst="rect">
@@ -3211,7 +3214,24 @@
               </a:defRPr>
             </a:pPr>
             <a:r>
-              <a:t>De l'invisible au finançable.</a:t>
+              <a:rPr dirty="0"/>
+              <a:t>De </a:t>
+            </a:r>
+            <a:r>
+              <a:rPr dirty="0" err="1"/>
+              <a:t>l'invisible</a:t>
+            </a:r>
+            <a:r>
+              <a:rPr dirty="0"/>
+              <a:t> au </a:t>
+            </a:r>
+            <a:r>
+              <a:rPr dirty="0" err="1"/>
+              <a:t>finançable</a:t>
+            </a:r>
+            <a:r>
+              <a:rPr dirty="0"/>
+              <a:t>.</a:t>
             </a:r>
           </a:p>
         </p:txBody>
@@ -3329,6 +3349,7 @@
           <a:lstStyle/>
           <a:p>
             <a:pPr algn="ctr"/>
+            <a:endParaRPr/>
           </a:p>
         </p:txBody>
       </p:sp>
@@ -3449,6 +3470,7 @@
           <a:lstStyle/>
           <a:p>
             <a:pPr algn="ctr"/>
+            <a:endParaRPr/>
           </a:p>
         </p:txBody>
       </p:sp>
@@ -3569,6 +3591,7 @@
           <a:lstStyle/>
           <a:p>
             <a:pPr algn="ctr"/>
+            <a:endParaRPr/>
           </a:p>
         </p:txBody>
       </p:sp>
@@ -3688,6 +3711,7 @@
           <a:lstStyle/>
           <a:p>
             <a:pPr algn="ctr"/>
+            <a:endParaRPr/>
           </a:p>
         </p:txBody>
       </p:sp>
@@ -3772,7 +3796,7 @@
 </file>
 
 <file path=ppt/slides/slide2.xml><?xml version="1.0" encoding="utf-8"?>
-<p:sld xmlns:a="http://schemas.openxmlformats.org/drawingml/2006/main" xmlns:p="http://schemas.openxmlformats.org/presentationml/2006/main" xmlns:r="http://schemas.openxmlformats.org/officeDocument/2006/relationships">
+<p:sld xmlns:a="http://schemas.openxmlformats.org/drawingml/2006/main" xmlns:r="http://schemas.openxmlformats.org/officeDocument/2006/relationships" xmlns:p="http://schemas.openxmlformats.org/presentationml/2006/main">
   <p:cSld>
     <p:bg>
       <p:bgPr>
@@ -3788,7 +3812,14 @@
         <p:cNvGrpSpPr/>
         <p:nvPr/>
       </p:nvGrpSpPr>
-      <p:grpSpPr/>
+      <p:grpSpPr>
+        <a:xfrm>
+          <a:off x="0" y="0"/>
+          <a:ext cx="0" cy="0"/>
+          <a:chOff x="0" y="0"/>
+          <a:chExt cx="0" cy="0"/>
+        </a:xfrm>
+      </p:grpSpPr>
       <p:sp>
         <p:nvSpPr>
           <p:cNvPr id="2" name="TextBox 1"/>
@@ -3869,7 +3900,7 @@
         </p:nvSpPr>
         <p:spPr>
           <a:xfrm>
-            <a:off x="731520" y="1554480"/>
+            <a:off x="731520" y="1828800"/>
             <a:ext cx="8229600" cy="548640"/>
           </a:xfrm>
           <a:prstGeom prst="rect">
@@ -3892,7 +3923,96 @@
               </a:defRPr>
             </a:pPr>
             <a:r>
-              <a:t>Pas parce qu'ils ne sont pas fiables — parce qu'ils n'ont aucune preuve exploitable de leur activité économique.</a:t>
+              <a:rPr dirty="0"/>
+              <a:t>Pas </a:t>
+            </a:r>
+            <a:r>
+              <a:rPr dirty="0" err="1"/>
+              <a:t>parce</a:t>
+            </a:r>
+            <a:r>
+              <a:rPr dirty="0"/>
+              <a:t> </a:t>
+            </a:r>
+            <a:r>
+              <a:rPr dirty="0" err="1"/>
+              <a:t>qu'ils</a:t>
+            </a:r>
+            <a:r>
+              <a:rPr dirty="0"/>
+              <a:t> ne </a:t>
+            </a:r>
+            <a:r>
+              <a:rPr dirty="0" err="1"/>
+              <a:t>sont</a:t>
+            </a:r>
+            <a:r>
+              <a:rPr dirty="0"/>
+              <a:t> pas </a:t>
+            </a:r>
+            <a:r>
+              <a:rPr dirty="0" err="1"/>
+              <a:t>fiables</a:t>
+            </a:r>
+            <a:r>
+              <a:rPr dirty="0"/>
+              <a:t> — </a:t>
+            </a:r>
+            <a:r>
+              <a:rPr dirty="0" err="1"/>
+              <a:t>parce</a:t>
+            </a:r>
+            <a:r>
+              <a:rPr dirty="0"/>
+              <a:t> </a:t>
+            </a:r>
+            <a:r>
+              <a:rPr dirty="0" err="1"/>
+              <a:t>qu'ils</a:t>
+            </a:r>
+            <a:r>
+              <a:rPr dirty="0"/>
+              <a:t> </a:t>
+            </a:r>
+            <a:r>
+              <a:rPr dirty="0" err="1"/>
+              <a:t>n'ont</a:t>
+            </a:r>
+            <a:r>
+              <a:rPr dirty="0"/>
+              <a:t> </a:t>
+            </a:r>
+            <a:r>
+              <a:rPr dirty="0" err="1"/>
+              <a:t>aucune</a:t>
+            </a:r>
+            <a:r>
+              <a:rPr dirty="0"/>
+              <a:t> </a:t>
+            </a:r>
+            <a:r>
+              <a:rPr dirty="0" err="1"/>
+              <a:t>preuve</a:t>
+            </a:r>
+            <a:r>
+              <a:rPr dirty="0"/>
+              <a:t> exploitable de </a:t>
+            </a:r>
+            <a:r>
+              <a:rPr dirty="0" err="1"/>
+              <a:t>leur</a:t>
+            </a:r>
+            <a:r>
+              <a:rPr dirty="0"/>
+              <a:t> </a:t>
+            </a:r>
+            <a:r>
+              <a:rPr dirty="0" err="1"/>
+              <a:t>activité</a:t>
+            </a:r>
+            <a:r>
+              <a:rPr dirty="0"/>
+              <a:t> économique.</a:t>
             </a:r>
           </a:p>
         </p:txBody>
@@ -3938,6 +4058,7 @@
           <a:lstStyle/>
           <a:p>
             <a:pPr algn="ctr"/>
+            <a:endParaRPr/>
           </a:p>
         </p:txBody>
       </p:sp>
@@ -3981,6 +4102,7 @@
           <a:lstStyle/>
           <a:p>
             <a:pPr algn="ctr"/>
+            <a:endParaRPr/>
           </a:p>
         </p:txBody>
       </p:sp>
@@ -4137,6 +4259,7 @@
           <a:lstStyle/>
           <a:p>
             <a:pPr algn="ctr"/>
+            <a:endParaRPr/>
           </a:p>
         </p:txBody>
       </p:sp>
@@ -4180,6 +4303,7 @@
           <a:lstStyle/>
           <a:p>
             <a:pPr algn="ctr"/>
+            <a:endParaRPr/>
           </a:p>
         </p:txBody>
       </p:sp>
@@ -4336,6 +4460,7 @@
           <a:lstStyle/>
           <a:p>
             <a:pPr algn="ctr"/>
+            <a:endParaRPr/>
           </a:p>
         </p:txBody>
       </p:sp>
@@ -4379,6 +4504,7 @@
           <a:lstStyle/>
           <a:p>
             <a:pPr algn="ctr"/>
+            <a:endParaRPr/>
           </a:p>
         </p:txBody>
       </p:sp>
@@ -4499,7 +4625,7 @@
 </file>
 
 <file path=ppt/slides/slide3.xml><?xml version="1.0" encoding="utf-8"?>
-<p:sld xmlns:a="http://schemas.openxmlformats.org/drawingml/2006/main" xmlns:p="http://schemas.openxmlformats.org/presentationml/2006/main" xmlns:r="http://schemas.openxmlformats.org/officeDocument/2006/relationships">
+<p:sld xmlns:a="http://schemas.openxmlformats.org/drawingml/2006/main" xmlns:r="http://schemas.openxmlformats.org/officeDocument/2006/relationships" xmlns:p="http://schemas.openxmlformats.org/presentationml/2006/main">
   <p:cSld>
     <p:bg>
       <p:bgPr>
@@ -4515,7 +4641,14 @@
         <p:cNvGrpSpPr/>
         <p:nvPr/>
       </p:nvGrpSpPr>
-      <p:grpSpPr/>
+      <p:grpSpPr>
+        <a:xfrm>
+          <a:off x="0" y="0"/>
+          <a:ext cx="0" cy="0"/>
+          <a:chOff x="0" y="0"/>
+          <a:chExt cx="0" cy="0"/>
+        </a:xfrm>
+      </p:grpSpPr>
       <p:sp>
         <p:nvSpPr>
           <p:cNvPr id="2" name="TextBox 1"/>
@@ -4596,7 +4729,7 @@
         </p:nvSpPr>
         <p:spPr>
           <a:xfrm>
-            <a:off x="731520" y="1554480"/>
+            <a:off x="777240" y="1847088"/>
             <a:ext cx="8229600" cy="548640"/>
           </a:xfrm>
           <a:prstGeom prst="rect">
@@ -4619,7 +4752,68 @@
               </a:defRPr>
             </a:pPr>
             <a:r>
-              <a:t>FresCoop capture automatiquement l'activité économique réelle et la transforme en dossier bancaire portable — sans changer les habitudes de l'agriculteur.</a:t>
+              <a:rPr dirty="0" err="1"/>
+              <a:t>FresCoop</a:t>
+            </a:r>
+            <a:r>
+              <a:rPr dirty="0"/>
+              <a:t> capture </a:t>
+            </a:r>
+            <a:r>
+              <a:rPr dirty="0" err="1"/>
+              <a:t>automatiquement</a:t>
+            </a:r>
+            <a:r>
+              <a:rPr dirty="0"/>
+              <a:t> </a:t>
+            </a:r>
+            <a:r>
+              <a:rPr dirty="0" err="1"/>
+              <a:t>l'activité</a:t>
+            </a:r>
+            <a:r>
+              <a:rPr dirty="0"/>
+              <a:t> économique </a:t>
+            </a:r>
+            <a:r>
+              <a:rPr dirty="0" err="1"/>
+              <a:t>réelle</a:t>
+            </a:r>
+            <a:r>
+              <a:rPr dirty="0"/>
+              <a:t> et la </a:t>
+            </a:r>
+            <a:r>
+              <a:rPr dirty="0" err="1"/>
+              <a:t>transforme</a:t>
+            </a:r>
+            <a:r>
+              <a:rPr dirty="0"/>
+              <a:t> </a:t>
+            </a:r>
+            <a:r>
+              <a:rPr dirty="0" err="1"/>
+              <a:t>en</a:t>
+            </a:r>
+            <a:r>
+              <a:rPr dirty="0"/>
+              <a:t> dossier </a:t>
+            </a:r>
+            <a:r>
+              <a:rPr dirty="0" err="1"/>
+              <a:t>bancaire</a:t>
+            </a:r>
+            <a:r>
+              <a:rPr dirty="0"/>
+              <a:t> portable — sans changer les habitudes de </a:t>
+            </a:r>
+            <a:r>
+              <a:rPr dirty="0" err="1"/>
+              <a:t>l'agriculteur</a:t>
+            </a:r>
+            <a:r>
+              <a:rPr dirty="0"/>
+              <a:t>.</a:t>
             </a:r>
           </a:p>
         </p:txBody>
@@ -4665,6 +4859,7 @@
           <a:lstStyle/>
           <a:p>
             <a:pPr algn="ctr"/>
+            <a:endParaRPr/>
           </a:p>
         </p:txBody>
       </p:sp>
@@ -4708,6 +4903,7 @@
           <a:lstStyle/>
           <a:p>
             <a:pPr algn="ctr"/>
+            <a:endParaRPr/>
           </a:p>
         </p:txBody>
       </p:sp>
@@ -4860,6 +5056,7 @@
           <a:lstStyle/>
           <a:p>
             <a:pPr algn="ctr"/>
+            <a:endParaRPr/>
           </a:p>
         </p:txBody>
       </p:sp>
@@ -4903,6 +5100,7 @@
           <a:lstStyle/>
           <a:p>
             <a:pPr algn="ctr"/>
+            <a:endParaRPr/>
           </a:p>
         </p:txBody>
       </p:sp>
@@ -5055,6 +5253,7 @@
           <a:lstStyle/>
           <a:p>
             <a:pPr algn="ctr"/>
+            <a:endParaRPr/>
           </a:p>
         </p:txBody>
       </p:sp>
@@ -5098,6 +5297,7 @@
           <a:lstStyle/>
           <a:p>
             <a:pPr algn="ctr"/>
+            <a:endParaRPr/>
           </a:p>
         </p:txBody>
       </p:sp>
@@ -5250,6 +5450,7 @@
           <a:lstStyle/>
           <a:p>
             <a:pPr algn="ctr"/>
+            <a:endParaRPr/>
           </a:p>
         </p:txBody>
       </p:sp>
@@ -5293,6 +5494,7 @@
           <a:lstStyle/>
           <a:p>
             <a:pPr algn="ctr"/>
+            <a:endParaRPr/>
           </a:p>
         </p:txBody>
       </p:sp>
@@ -5445,6 +5647,7 @@
           <a:lstStyle/>
           <a:p>
             <a:pPr algn="ctr"/>
+            <a:endParaRPr/>
           </a:p>
         </p:txBody>
       </p:sp>
@@ -5488,6 +5691,7 @@
           <a:lstStyle/>
           <a:p>
             <a:pPr algn="ctr"/>
+            <a:endParaRPr/>
           </a:p>
         </p:txBody>
       </p:sp>
@@ -5608,7 +5812,7 @@
 </file>
 
 <file path=ppt/slides/slide4.xml><?xml version="1.0" encoding="utf-8"?>
-<p:sld xmlns:a="http://schemas.openxmlformats.org/drawingml/2006/main" xmlns:p="http://schemas.openxmlformats.org/presentationml/2006/main" xmlns:r="http://schemas.openxmlformats.org/officeDocument/2006/relationships">
+<p:sld xmlns:a="http://schemas.openxmlformats.org/drawingml/2006/main" xmlns:r="http://schemas.openxmlformats.org/officeDocument/2006/relationships" xmlns:p="http://schemas.openxmlformats.org/presentationml/2006/main">
   <p:cSld>
     <p:bg>
       <p:bgPr>
@@ -5624,7 +5828,14 @@
         <p:cNvGrpSpPr/>
         <p:nvPr/>
       </p:nvGrpSpPr>
-      <p:grpSpPr/>
+      <p:grpSpPr>
+        <a:xfrm>
+          <a:off x="0" y="0"/>
+          <a:ext cx="0" cy="0"/>
+          <a:chOff x="0" y="0"/>
+          <a:chExt cx="0" cy="0"/>
+        </a:xfrm>
+      </p:grpSpPr>
       <p:sp>
         <p:nvSpPr>
           <p:cNvPr id="2" name="TextBox 1"/>
@@ -5738,6 +5949,7 @@
           <a:lstStyle/>
           <a:p>
             <a:pPr algn="ctr"/>
+            <a:endParaRPr/>
           </a:p>
         </p:txBody>
       </p:sp>
@@ -5818,6 +6030,7 @@
           <a:lstStyle/>
           <a:p>
             <a:pPr algn="ctr"/>
+            <a:endParaRPr/>
           </a:p>
         </p:txBody>
       </p:sp>
@@ -5970,6 +6183,7 @@
           <a:lstStyle/>
           <a:p>
             <a:pPr algn="ctr"/>
+            <a:endParaRPr/>
           </a:p>
         </p:txBody>
       </p:sp>
@@ -6122,6 +6336,7 @@
           <a:lstStyle/>
           <a:p>
             <a:pPr algn="ctr"/>
+            <a:endParaRPr/>
           </a:p>
         </p:txBody>
       </p:sp>
@@ -6238,6 +6453,7 @@
           <a:lstStyle/>
           <a:p>
             <a:pPr algn="ctr"/>
+            <a:endParaRPr/>
           </a:p>
         </p:txBody>
       </p:sp>
@@ -6281,6 +6497,7 @@
           <a:lstStyle/>
           <a:p>
             <a:pPr algn="ctr"/>
+            <a:endParaRPr/>
           </a:p>
         </p:txBody>
       </p:sp>
@@ -6469,6 +6686,7 @@
           <a:lstStyle/>
           <a:p>
             <a:pPr algn="ctr"/>
+            <a:endParaRPr/>
           </a:p>
         </p:txBody>
       </p:sp>
@@ -6512,6 +6730,7 @@
           <a:lstStyle/>
           <a:p>
             <a:pPr algn="ctr"/>
+            <a:endParaRPr/>
           </a:p>
         </p:txBody>
       </p:sp>
@@ -6700,6 +6919,7 @@
           <a:lstStyle/>
           <a:p>
             <a:pPr algn="ctr"/>
+            <a:endParaRPr/>
           </a:p>
         </p:txBody>
       </p:sp>
@@ -6743,6 +6963,7 @@
           <a:lstStyle/>
           <a:p>
             <a:pPr algn="ctr"/>
+            <a:endParaRPr/>
           </a:p>
         </p:txBody>
       </p:sp>
@@ -6931,6 +7152,7 @@
           <a:lstStyle/>
           <a:p>
             <a:pPr algn="ctr"/>
+            <a:endParaRPr/>
           </a:p>
         </p:txBody>
       </p:sp>
@@ -7083,6 +7305,7 @@
           <a:lstStyle/>
           <a:p>
             <a:pPr algn="ctr"/>
+            <a:endParaRPr/>
           </a:p>
         </p:txBody>
       </p:sp>
@@ -7235,6 +7458,7 @@
           <a:lstStyle/>
           <a:p>
             <a:pPr algn="ctr"/>
+            <a:endParaRPr/>
           </a:p>
         </p:txBody>
       </p:sp>
@@ -7387,6 +7611,7 @@
           <a:lstStyle/>
           <a:p>
             <a:pPr algn="ctr"/>
+            <a:endParaRPr/>
           </a:p>
         </p:txBody>
       </p:sp>
@@ -7507,7 +7732,7 @@
 </file>
 
 <file path=ppt/slides/slide5.xml><?xml version="1.0" encoding="utf-8"?>
-<p:sld xmlns:a="http://schemas.openxmlformats.org/drawingml/2006/main" xmlns:p="http://schemas.openxmlformats.org/presentationml/2006/main" xmlns:r="http://schemas.openxmlformats.org/officeDocument/2006/relationships">
+<p:sld xmlns:a="http://schemas.openxmlformats.org/drawingml/2006/main" xmlns:r="http://schemas.openxmlformats.org/officeDocument/2006/relationships" xmlns:p="http://schemas.openxmlformats.org/presentationml/2006/main">
   <p:cSld>
     <p:bg>
       <p:bgPr>
@@ -7523,7 +7748,14 @@
         <p:cNvGrpSpPr/>
         <p:nvPr/>
       </p:nvGrpSpPr>
-      <p:grpSpPr/>
+      <p:grpSpPr>
+        <a:xfrm>
+          <a:off x="0" y="0"/>
+          <a:ext cx="0" cy="0"/>
+          <a:chOff x="0" y="0"/>
+          <a:chExt cx="0" cy="0"/>
+        </a:xfrm>
+      </p:grpSpPr>
       <p:sp>
         <p:nvSpPr>
           <p:cNvPr id="2" name="TextBox 1"/>
@@ -7637,6 +7869,7 @@
           <a:lstStyle/>
           <a:p>
             <a:pPr algn="ctr"/>
+            <a:endParaRPr/>
           </a:p>
         </p:txBody>
       </p:sp>
@@ -7757,6 +7990,7 @@
           <a:lstStyle/>
           <a:p>
             <a:pPr algn="ctr"/>
+            <a:endParaRPr/>
           </a:p>
         </p:txBody>
       </p:sp>
@@ -7877,6 +8111,7 @@
           <a:lstStyle/>
           <a:p>
             <a:pPr algn="ctr"/>
+            <a:endParaRPr/>
           </a:p>
         </p:txBody>
       </p:sp>
@@ -7997,6 +8232,7 @@
           <a:lstStyle/>
           <a:p>
             <a:pPr algn="ctr"/>
+            <a:endParaRPr/>
           </a:p>
         </p:txBody>
       </p:sp>
@@ -8153,6 +8389,7 @@
           <a:lstStyle/>
           <a:p>
             <a:pPr algn="ctr"/>
+            <a:endParaRPr/>
           </a:p>
         </p:txBody>
       </p:sp>
@@ -8269,6 +8506,7 @@
           <a:lstStyle/>
           <a:p>
             <a:pPr algn="ctr"/>
+            <a:endParaRPr/>
           </a:p>
         </p:txBody>
       </p:sp>
@@ -8385,6 +8623,7 @@
           <a:lstStyle/>
           <a:p>
             <a:pPr algn="ctr"/>
+            <a:endParaRPr/>
           </a:p>
         </p:txBody>
       </p:sp>
@@ -8501,6 +8740,7 @@
           <a:lstStyle/>
           <a:p>
             <a:pPr algn="ctr"/>
+            <a:endParaRPr/>
           </a:p>
         </p:txBody>
       </p:sp>
@@ -8585,7 +8825,7 @@
 </file>
 
 <file path=ppt/slides/slide6.xml><?xml version="1.0" encoding="utf-8"?>
-<p:sld xmlns:a="http://schemas.openxmlformats.org/drawingml/2006/main" xmlns:p="http://schemas.openxmlformats.org/presentationml/2006/main" xmlns:r="http://schemas.openxmlformats.org/officeDocument/2006/relationships">
+<p:sld xmlns:a="http://schemas.openxmlformats.org/drawingml/2006/main" xmlns:r="http://schemas.openxmlformats.org/officeDocument/2006/relationships" xmlns:p="http://schemas.openxmlformats.org/presentationml/2006/main">
   <p:cSld>
     <p:bg>
       <p:bgPr>
@@ -8601,7 +8841,14 @@
         <p:cNvGrpSpPr/>
         <p:nvPr/>
       </p:nvGrpSpPr>
-      <p:grpSpPr/>
+      <p:grpSpPr>
+        <a:xfrm>
+          <a:off x="0" y="0"/>
+          <a:ext cx="0" cy="0"/>
+          <a:chOff x="0" y="0"/>
+          <a:chExt cx="0" cy="0"/>
+        </a:xfrm>
+      </p:grpSpPr>
       <p:sp>
         <p:nvSpPr>
           <p:cNvPr id="2" name="Rectangle 1"/>
@@ -8642,6 +8889,7 @@
           <a:lstStyle/>
           <a:p>
             <a:pPr algn="ctr"/>
+            <a:endParaRPr/>
           </a:p>
         </p:txBody>
       </p:sp>
@@ -8802,6 +9050,7 @@
           <a:lstStyle/>
           <a:p>
             <a:pPr algn="ctr"/>
+            <a:endParaRPr/>
           </a:p>
         </p:txBody>
       </p:sp>
@@ -8953,6 +9202,7 @@
           <a:lstStyle/>
           <a:p>
             <a:pPr algn="ctr"/>
+            <a:endParaRPr/>
           </a:p>
         </p:txBody>
       </p:sp>

</xml_diff>